<commit_message>
Add temporal GNN pipeline, Streamlit dashboard and results; fill presentation with real values and figures
Co-Authored-By: Claude Sonnet 5.5 <noreply@anthropic.com>
Claude-Session: https://claude.ai/code/session_01D8p93zoBdXkqrFwsNpsZMi
</commit_message>
<xml_diff>
--- a/FraudScope_DL_Project_Implementation.pptx
+++ b/FraudScope_DL_Project_Implementation.pptx
@@ -20,6 +20,7 @@
     <p:sldId id="309" r:id="rId14"/>
     <p:sldId id="310" r:id="rId15"/>
     <p:sldId id="311" r:id="rId16"/>
+    <p:sldId id="316" r:id="rId24"/>
     <p:sldId id="312" r:id="rId17"/>
     <p:sldId id="298" r:id="rId18"/>
     <p:sldId id="313" r:id="rId19"/>
@@ -3716,7 +3717,7 @@
                           <a:latin typeface="Times New Roman" panose="02020603050405020304" pitchFamily="18" charset="0"/>
                           <a:cs typeface="Times New Roman" panose="02020603050405020304" pitchFamily="18" charset="0"/>
                         </a:rPr>
-                        <a:t>PyTorch Geometric (PyG) [confirm PyTorch version]</a:t>
+                        <a:t>PyTorch Geometric (PyG) 2.8.1 on PyTorch 2.15.0</a:t>
                       </a:r>
                       <a:endParaRPr lang="en-IN" sz="2000">
                         <a:latin typeface="Times New Roman" panose="02020603050405020304" pitchFamily="18" charset="0"/>
@@ -3833,7 +3834,7 @@
                           <a:latin typeface="Times New Roman" panose="02020603050405020304" pitchFamily="18" charset="0"/>
                           <a:cs typeface="Times New Roman" panose="02020603050405020304" pitchFamily="18" charset="0"/>
                         </a:rPr>
-                        <a:t>[Google Colab / Jupyter / VS Code]</a:t>
+                        <a:t>Cloud Linux container, Python scripts (train.py, report.py)</a:t>
                       </a:r>
                       <a:endParaRPr lang="en-IN" sz="2000">
                         <a:latin typeface="Times New Roman" panose="02020603050405020304" pitchFamily="18" charset="0"/>
@@ -4067,7 +4068,7 @@
                           <a:latin typeface="Times New Roman" panose="02020603050405020304" pitchFamily="18" charset="0"/>
                           <a:cs typeface="Times New Roman" panose="02020603050405020304" pitchFamily="18" charset="0"/>
                         </a:rPr>
-                        <a:t>[CPU / GPU details]</a:t>
+                        <a:t>CPU only: 4 cores, 15 GB RAM, no GPU</a:t>
                       </a:r>
                       <a:endParaRPr lang="en-IN" sz="2000" dirty="0">
                         <a:latin typeface="Times New Roman" panose="02020603050405020304" pitchFamily="18" charset="0"/>
@@ -4449,13 +4450,13 @@
           <a:p>
             <a:r>
               <a:rPr lang="en-US" sz="1500" dirty="0"/>
-              <a:t>Loss and optimizer: binary cross-entropy; optimizer [fill].</a:t>
+              <a:t>Loss and optimizer: binary cross-entropy (positive-class weighted); optimizer Adam.</a:t>
             </a:r>
           </a:p>
           <a:p>
             <a:r>
               <a:rPr lang="en-US" sz="1500" dirty="0"/>
-              <a:t>Learning rate, batch size, epochs: [fill from code].</a:t>
+              <a:t>Learning rate, batch size, epochs: learning rate 0.005, full-batch (one temporal graph of 5,000 nodes per window), up to 200 epochs with early stopping (patience 30).</a:t>
             </a:r>
           </a:p>
           <a:p>
@@ -4482,14 +4483,37 @@
             </a:pPr>
             <a:endParaRPr lang="en-US" sz="1500" dirty="0"/>
           </a:p>
-          <a:p>
-            <a:r>
-              <a:rPr lang="en-US" sz="1500" dirty="0"/>
-              <a:t>[Insert code snippets / implementation flow screenshot]</a:t>
-            </a:r>
-          </a:p>
         </p:txBody>
       </p:sp>
+      <p:pic>
+        <p:nvPicPr>
+          <p:cNvPr id="4" name="Screenshot Code" descr="Temporal GNN layer and training loop code"/>
+          <p:cNvPicPr>
+            <a:picLocks noChangeAspect="1"/>
+          </p:cNvPicPr>
+          <p:nvPr/>
+        </p:nvPicPr>
+        <p:blipFill>
+          <a:blip r:embed="rId2"/>
+          <a:stretch>
+            <a:fillRect/>
+          </a:stretch>
+        </p:blipFill>
+        <p:spPr>
+          <a:xfrm>
+            <a:off x="914400" y="3703320"/>
+            <a:ext cx="7315200" cy="2417379"/>
+          </a:xfrm>
+          <a:prstGeom prst="rect">
+            <a:avLst/>
+          </a:prstGeom>
+          <a:ln w="9144">
+            <a:solidFill>
+              <a:srgbClr val="999999"/>
+            </a:solidFill>
+          </a:ln>
+        </p:spPr>
+      </p:pic>
     </p:spTree>
     <p:extLst>
       <p:ext uri="{BB962C8B-B14F-4D97-AF65-F5344CB8AC3E}">
@@ -4577,47 +4601,70 @@
           <a:p>
             <a:r>
               <a:rPr lang="en-US" sz="1600" dirty="0"/>
-              <a:t>Dataset sizes (train / validation / test): [fill].</a:t>
+              <a:t>Dataset sizes (train / validation / test): 58,341 / 19,722 / 19,768 transactions; 518 / 204 / 205 fraud accounts out of 5,000.</a:t>
             </a:r>
           </a:p>
           <a:p>
             <a:r>
               <a:rPr lang="en-US" sz="1600" dirty="0"/>
-              <a:t>Hyperparameters: [learning rate, hidden size, layers, dropout].</a:t>
+              <a:t>Hyperparameters: learning rate 0.005, hidden size 64, 2 layers, dropout 0.3, weight decay 0.001 (grid-searched on validation PR-AUC).</a:t>
             </a:r>
           </a:p>
           <a:p>
             <a:r>
               <a:rPr lang="en-US" sz="1600" dirty="0"/>
-              <a:t>Epochs completed: [fill].</a:t>
+              <a:t>Epochs completed: Temporal GNN 52-55 (best epoch 22-25), GraphSAGE 97-109 (best epoch 67-79), over 3 seeds.</a:t>
             </a:r>
           </a:p>
           <a:p>
             <a:r>
               <a:rPr lang="en-US" sz="1600" dirty="0"/>
-              <a:t>Training time and hardware: [fill].</a:t>
+              <a:t>Training time and hardware: about 13 s (Temporal GNN) and 5 s (GraphSAGE) per run on a 4-core CPU, no GPU.</a:t>
             </a:r>
           </a:p>
           <a:p>
             <a:r>
               <a:rPr lang="en-US" sz="1600" dirty="0"/>
-              <a:t>Imbalance handling and feature variants tested: [fill].</a:t>
+              <a:t>Imbalance handling and feature variants tested: positive-class weighted BCE and an F1-optimal threshold chosen on validation; mean-only vs mean + max aggregation (mean + max kept).</a:t>
             </a:r>
           </a:p>
           <a:p>
             <a:r>
               <a:rPr lang="en-US" sz="1600" dirty="0"/>
-              <a:t>Metrics: precision, recall, F1, ROC-AUC (accuracy is not used because it misleads on 99,000 normal vs 1,000 fraud).</a:t>
-            </a:r>
-          </a:p>
-          <a:p>
-            <a:r>
-              <a:rPr lang="en-US" sz="1600" dirty="0"/>
-              <a:t>[Insert training and validation loss curves]</a:t>
+              <a:t>Metrics: precision, recall, F1, ROC-AUC (accuracy is not used because it misleads on 96,841 normal vs 990 fraud).</a:t>
             </a:r>
           </a:p>
         </p:txBody>
       </p:sp>
+      <p:pic>
+        <p:nvPicPr>
+          <p:cNvPr id="4" name="Figure Loss" descr="Training and validation loss curves"/>
+          <p:cNvPicPr>
+            <a:picLocks noChangeAspect="1"/>
+          </p:cNvPicPr>
+          <p:nvPr/>
+        </p:nvPicPr>
+        <p:blipFill>
+          <a:blip r:embed="rId2"/>
+          <a:stretch>
+            <a:fillRect/>
+          </a:stretch>
+        </p:blipFill>
+        <p:spPr>
+          <a:xfrm>
+            <a:off x="1828800" y="4572000"/>
+            <a:ext cx="5486400" cy="2194560"/>
+          </a:xfrm>
+          <a:prstGeom prst="rect">
+            <a:avLst/>
+          </a:prstGeom>
+          <a:ln w="9144">
+            <a:solidFill>
+              <a:srgbClr val="999999"/>
+            </a:solidFill>
+          </a:ln>
+        </p:spPr>
+      </p:pic>
     </p:spTree>
     <p:extLst>
       <p:ext uri="{BB962C8B-B14F-4D97-AF65-F5344CB8AC3E}">
@@ -4709,22 +4756,95 @@
             </a:pPr>
             <a:endParaRPr lang="en-IN" dirty="0"/>
           </a:p>
-          <a:p>
-            <a:r>
-              <a:rPr lang="en-US" sz="1800" dirty="0"/>
-              <a:t>[Insert results table: Random Forest | GraphSAGE | Temporal GNN]</a:t>
-            </a:r>
-            <a:endParaRPr lang="en-IN" dirty="0"/>
-          </a:p>
-          <a:p>
-            <a:r>
-              <a:rPr lang="en-US" sz="1800" dirty="0"/>
-              <a:t>[Insert ROC curve and confusion matrix]</a:t>
-            </a:r>
-            <a:endParaRPr lang="en-IN" dirty="0"/>
-          </a:p>
         </p:txBody>
       </p:sp>
+      <p:pic>
+        <p:nvPicPr>
+          <p:cNvPr id="4" name="Figure Results" descr="Results table"/>
+          <p:cNvPicPr>
+            <a:picLocks noChangeAspect="1"/>
+          </p:cNvPicPr>
+          <p:nvPr/>
+        </p:nvPicPr>
+        <p:blipFill>
+          <a:blip r:embed="rId2"/>
+          <a:stretch>
+            <a:fillRect/>
+          </a:stretch>
+        </p:blipFill>
+        <p:spPr>
+          <a:xfrm>
+            <a:off x="1371600" y="1737360"/>
+            <a:ext cx="6400800" cy="1837418"/>
+          </a:xfrm>
+          <a:prstGeom prst="rect">
+            <a:avLst/>
+          </a:prstGeom>
+          <a:ln w="9144">
+            <a:solidFill>
+              <a:srgbClr val="999999"/>
+            </a:solidFill>
+          </a:ln>
+        </p:spPr>
+      </p:pic>
+      <p:pic>
+        <p:nvPicPr>
+          <p:cNvPr id="5" name="Figure ROC" descr="ROC curves"/>
+          <p:cNvPicPr>
+            <a:picLocks noChangeAspect="1"/>
+          </p:cNvPicPr>
+          <p:nvPr/>
+        </p:nvPicPr>
+        <p:blipFill>
+          <a:blip r:embed="rId3"/>
+          <a:stretch>
+            <a:fillRect/>
+          </a:stretch>
+        </p:blipFill>
+        <p:spPr>
+          <a:xfrm>
+            <a:off x="457200" y="3794760"/>
+            <a:ext cx="3004457" cy="2743200"/>
+          </a:xfrm>
+          <a:prstGeom prst="rect">
+            <a:avLst/>
+          </a:prstGeom>
+          <a:ln w="9144">
+            <a:solidFill>
+              <a:srgbClr val="999999"/>
+            </a:solidFill>
+          </a:ln>
+        </p:spPr>
+      </p:pic>
+      <p:pic>
+        <p:nvPicPr>
+          <p:cNvPr id="6" name="Figure Confusion" descr="Confusion matrices"/>
+          <p:cNvPicPr>
+            <a:picLocks noChangeAspect="1"/>
+          </p:cNvPicPr>
+          <p:nvPr/>
+        </p:nvPicPr>
+        <p:blipFill>
+          <a:blip r:embed="rId4"/>
+          <a:stretch>
+            <a:fillRect/>
+          </a:stretch>
+        </p:blipFill>
+        <p:spPr>
+          <a:xfrm>
+            <a:off x="3611880" y="4114800"/>
+            <a:ext cx="5212080" cy="1772107"/>
+          </a:xfrm>
+          <a:prstGeom prst="rect">
+            <a:avLst/>
+          </a:prstGeom>
+          <a:ln w="9144">
+            <a:solidFill>
+              <a:srgbClr val="999999"/>
+            </a:solidFill>
+          </a:ln>
+        </p:spPr>
+      </p:pic>
     </p:spTree>
     <p:extLst>
       <p:ext uri="{BB962C8B-B14F-4D97-AF65-F5344CB8AC3E}">
@@ -4819,7 +4939,7 @@
           <a:p>
             <a:r>
               <a:rPr lang="en-US" sz="1600" dirty="0"/>
-              <a:t>Question tested: does temporal behaviour beat tabular and static GNN baselines? Literature (GTCT ablation) suggests temporal encoders add recall and AUC. [State actual outcome]</a:t>
+              <a:t>Question tested: does temporal behaviour beat tabular and static GNN baselines? Literature (GTCT ablation) suggests temporal encoders add recall and AUC. Outcome: on the future test window the Temporal GNN reached F1 0.969 and ROC-AUC 1.000, against 0.839 / 0.988 for GraphSAGE, 0.785 / 0.947 for Random Forest and 0.306 / 0.769 for Isolation Forest; recall rose to 0.972 from 0.800 and 0.663. Rule-based detectors were not scored separately. These are synthetic-data results.</a:t>
             </a:r>
           </a:p>
         </p:txBody>
@@ -4905,31 +5025,13 @@
           <a:p>
             <a:r>
               <a:rPr lang="en-US" sz="1600" dirty="0"/>
-              <a:t>FraudScope dashboard: risk score, reasons and suspicious graph per account [insert screenshot].</a:t>
+              <a:t>FundTrace AI demo: live transaction stream, alert "Layering chain detected - CRITICAL", animated red laundering path in the fund flow graph.</a:t>
             </a:r>
           </a:p>
           <a:p>
             <a:r>
               <a:rPr lang="en-US" sz="1600" dirty="0"/>
-              <a:t>FundTrace AI demo: live transaction stream, alert "Layering chain detected - CRITICAL", animated red laundering path in the fund flow graph [insert screenshot].</a:t>
-            </a:r>
-          </a:p>
-          <a:p>
-            <a:r>
-              <a:rPr lang="en-US" sz="1600" dirty="0"/>
-              <a:t>Case workspace with notes and one-click STR PDF report [insert screenshot].</a:t>
-            </a:r>
-          </a:p>
-          <a:p>
-            <a:r>
-              <a:rPr lang="en-US" sz="1600" dirty="0"/>
-              <a:t>Correct and incorrect predictions [insert examples].</a:t>
-            </a:r>
-          </a:p>
-          <a:p>
-            <a:r>
-              <a:rPr lang="en-US" sz="1600" dirty="0"/>
-              <a:t>Confusion matrix and plots [insert].</a:t>
+              <a:t>Case workspace with notes and one-click STR PDF report.</a:t>
             </a:r>
           </a:p>
         </p:txBody>
@@ -5221,13 +5323,13 @@
           <a:p>
             <a:r>
               <a:rPr lang="en-US" sz="1500" b="0" dirty="0"/>
-              <a:t>Main results: [state actual precision, recall, F1, ROC-AUC].</a:t>
+              <a:t>Main results: Temporal GNN on the future test window: precision 0.967, recall 0.972, F1 0.969, ROC-AUC 1.000 (mean of 3 seeds, synthetic data).</a:t>
             </a:r>
           </a:p>
           <a:p>
             <a:r>
               <a:rPr lang="en-US" sz="1500" b="0" dirty="0"/>
-              <a:t>Objectives met: [state how far].</a:t>
+              <a:t>Objectives met: all four on simulated data (temporal graph built, three models compared leakage-free, scores with reasons and subgraph in the dashboard); validation on real bank data remains.</a:t>
             </a:r>
           </a:p>
           <a:p>
@@ -5397,7 +5499,7 @@
           <a:p>
             <a:r>
               <a:rPr lang="en-US" sz="1300" dirty="0"/>
-              <a:t>[9] Tools: PyTorch Geometric, NetworkX, scikit-learn, Pandas, Streamlit; FundTrace AI prototype (React, Node.js, FastAPI); dataset [add source].</a:t>
+              <a:t>[9] Tools: PyTorch Geometric, NetworkX, scikit-learn, Pandas, Streamlit; FundTrace AI prototype (React, Node.js, FastAPI); dataset synthetic transactions from ml-service/gnn/gen_data.py.</a:t>
             </a:r>
           </a:p>
         </p:txBody>
@@ -5406,6 +5508,191 @@
     <p:extLst>
       <p:ext uri="{BB962C8B-B14F-4D97-AF65-F5344CB8AC3E}">
         <p14:creationId xmlns:p14="http://schemas.microsoft.com/office/powerpoint/2010/main" val="574717569"/>
+      </p:ext>
+    </p:extLst>
+  </p:cSld>
+  <p:clrMapOvr>
+    <a:masterClrMapping/>
+  </p:clrMapOvr>
+</p:sld>
+</file>
+
+<file path=ppt/slides/slide19.xml><?xml version="1.0" encoding="utf-8"?>
+<p:sld xmlns:a="http://schemas.openxmlformats.org/drawingml/2006/main" xmlns:r="http://schemas.openxmlformats.org/officeDocument/2006/relationships" xmlns:p="http://schemas.openxmlformats.org/presentationml/2006/main">
+  <p:cSld>
+    <p:spTree>
+      <p:nvGrpSpPr>
+        <p:cNvPr id="1" name=""/>
+        <p:cNvGrpSpPr/>
+        <p:nvPr/>
+      </p:nvGrpSpPr>
+      <p:grpSpPr>
+        <a:xfrm>
+          <a:off x="0" y="0"/>
+          <a:ext cx="0" cy="0"/>
+          <a:chOff x="0" y="0"/>
+          <a:chExt cx="0" cy="0"/>
+        </a:xfrm>
+      </p:grpSpPr>
+      <p:sp>
+        <p:nvSpPr>
+          <p:cNvPr id="2" name="Title 1">
+            <a:extLst>
+              <a:ext uri="{FF2B5EF4-FFF2-40B4-BE49-F238E27FC236}">
+                <a16:creationId xmlns:a16="http://schemas.microsoft.com/office/drawing/2014/main" id="{D0C64E9D-9A46-8DC3-681C-2B1AC80BC010}"/>
+              </a:ext>
+            </a:extLst>
+          </p:cNvPr>
+          <p:cNvSpPr>
+            <a:spLocks noGrp="1"/>
+          </p:cNvSpPr>
+          <p:nvPr>
+            <p:ph type="title"/>
+          </p:nvPr>
+        </p:nvSpPr>
+        <p:spPr/>
+        <p:txBody>
+          <a:bodyPr/>
+          <a:lstStyle/>
+          <a:p>
+            <a:r>
+              <a:rPr lang="en-IN" dirty="0"/>
+              <a:t>Sample Outputs and Demonstration</a:t>
+            </a:r>
+          </a:p>
+        </p:txBody>
+      </p:sp>
+      <p:sp>
+        <p:nvSpPr>
+          <p:cNvPr id="3" name="Content Placeholder 2">
+            <a:extLst>
+              <a:ext uri="{FF2B5EF4-FFF2-40B4-BE49-F238E27FC236}">
+                <a16:creationId xmlns:a16="http://schemas.microsoft.com/office/drawing/2014/main" id="{7C956E8E-43B5-1B39-FBC8-4D979B9E7115}"/>
+              </a:ext>
+            </a:extLst>
+          </p:cNvPr>
+          <p:cNvSpPr>
+            <a:spLocks noGrp="1"/>
+          </p:cNvSpPr>
+          <p:nvPr>
+            <p:ph idx="1"/>
+          </p:nvPr>
+        </p:nvSpPr>
+        <p:spPr/>
+        <p:txBody>
+          <a:bodyPr/>
+          <a:lstStyle/>
+          <a:p>
+            <a:r>
+              <a:rPr lang="en-US" sz="1600" dirty="0"/>
+              <a:t>FraudScope dashboard: risk score, reasons and suspicious graph per account.</a:t>
+            </a:r>
+          </a:p>
+          <a:p>
+            <a:r>
+              <a:rPr lang="en-US" sz="1600" dirty="0"/>
+              <a:t>Correct and incorrect predictions.</a:t>
+            </a:r>
+          </a:p>
+          <a:p>
+            <a:r>
+              <a:rPr lang="en-US" sz="1600" dirty="0"/>
+              <a:t>Confusion matrix and plots.</a:t>
+            </a:r>
+          </a:p>
+        </p:txBody>
+      </p:sp>
+      <p:pic>
+        <p:nvPicPr>
+          <p:cNvPr id="4" name="Screenshot Streamlit" descr="Streamlit dashboard with risk score, reasons and suspicious subgraph"/>
+          <p:cNvPicPr>
+            <a:picLocks noChangeAspect="1"/>
+          </p:cNvPicPr>
+          <p:nvPr/>
+        </p:nvPicPr>
+        <p:blipFill>
+          <a:blip r:embed="rId5"/>
+          <a:stretch>
+            <a:fillRect/>
+          </a:stretch>
+        </p:blipFill>
+        <p:spPr>
+          <a:xfrm>
+            <a:off x="365760" y="2286000"/>
+            <a:ext cx="4023360" cy="2766060"/>
+          </a:xfrm>
+          <a:prstGeom prst="rect">
+            <a:avLst/>
+          </a:prstGeom>
+          <a:ln w="9144">
+            <a:solidFill>
+              <a:srgbClr val="999999"/>
+            </a:solidFill>
+          </a:ln>
+        </p:spPr>
+      </p:pic>
+      <p:pic>
+        <p:nvPicPr>
+          <p:cNvPr id="5" name="Figure Examples" descr="Correct and incorrect prediction examples"/>
+          <p:cNvPicPr>
+            <a:picLocks noChangeAspect="1"/>
+          </p:cNvPicPr>
+          <p:nvPr/>
+        </p:nvPicPr>
+        <p:blipFill>
+          <a:blip r:embed="rId6"/>
+          <a:stretch>
+            <a:fillRect/>
+          </a:stretch>
+        </p:blipFill>
+        <p:spPr>
+          <a:xfrm>
+            <a:off x="4526280" y="2286000"/>
+            <a:ext cx="4389120" cy="2244612"/>
+          </a:xfrm>
+          <a:prstGeom prst="rect">
+            <a:avLst/>
+          </a:prstGeom>
+          <a:ln w="9144">
+            <a:solidFill>
+              <a:srgbClr val="999999"/>
+            </a:solidFill>
+          </a:ln>
+        </p:spPr>
+      </p:pic>
+      <p:pic>
+        <p:nvPicPr>
+          <p:cNvPr id="6" name="Figure Confusion" descr="Confusion matrices"/>
+          <p:cNvPicPr>
+            <a:picLocks noChangeAspect="1"/>
+          </p:cNvPicPr>
+          <p:nvPr/>
+        </p:nvPicPr>
+        <p:blipFill>
+          <a:blip r:embed="rId7"/>
+          <a:stretch>
+            <a:fillRect/>
+          </a:stretch>
+        </p:blipFill>
+        <p:spPr>
+          <a:xfrm>
+            <a:off x="1920240" y="5029200"/>
+            <a:ext cx="5303520" cy="1803197"/>
+          </a:xfrm>
+          <a:prstGeom prst="rect">
+            <a:avLst/>
+          </a:prstGeom>
+          <a:ln w="9144">
+            <a:solidFill>
+              <a:srgbClr val="999999"/>
+            </a:solidFill>
+          </a:ln>
+        </p:spPr>
+      </p:pic>
+    </p:spTree>
+    <p:extLst>
+      <p:ext uri="{BB962C8B-B14F-4D97-AF65-F5344CB8AC3E}">
+        <p14:creationId xmlns:p14="http://schemas.microsoft.com/office/powerpoint/2010/main" val="34333297"/>
       </p:ext>
     </p:extLst>
   </p:cSld>
@@ -10154,19 +10441,19 @@
           <a:p>
             <a:r>
               <a:rPr lang="en-US" sz="1600" dirty="0"/>
-              <a:t>Dataset: Dummy Data</a:t>
+              <a:t>Dataset: synthetic transaction data following the FraudScope simulator patterns (30 days, 5,000 accounts, 97,831 transactions).</a:t>
             </a:r>
           </a:p>
           <a:p>
             <a:r>
               <a:rPr lang="en-US" sz="1600" dirty="0"/>
-              <a:t>Samples and classes: binary (fraud / normal), highly imbalanced, e.g. about 99,000 normal vs 1,000 fraud [update with actual counts].</a:t>
+              <a:t>Samples and classes: binary (fraud / normal), highly imbalanced: 96,841 normal vs 990 fraud transactions (1.0%); 518 / 204 / 205 fraud accounts out of 5,000 in the train / validation / test windows.</a:t>
             </a:r>
           </a:p>
           <a:p>
             <a:r>
               <a:rPr lang="en-US" sz="1600" dirty="0"/>
-              <a:t>Split: temporal, not random. Train on past, validate on a later window, test on the future [add exact ratios].</a:t>
+              <a:t>Split: temporal, not random. Train on past, validate on a later window, test on the future (days 1-18 train, 19-24 validation, 25-30 test; 58,341 / 19,722 / 19,768 transactions).</a:t>
             </a:r>
           </a:p>
           <a:p>
@@ -10186,12 +10473,6 @@
               <a:buNone/>
             </a:pPr>
             <a:endParaRPr lang="en-US" sz="1600" dirty="0"/>
-          </a:p>
-          <a:p>
-            <a:r>
-              <a:rPr lang="en-US" sz="1600" dirty="0"/>
-              <a:t>[Insert screenshot of dataset sample rows / transaction graph]</a:t>
-            </a:r>
           </a:p>
         </p:txBody>
       </p:sp>
@@ -10360,7 +10641,7 @@
             </a:pPr>
             <a:r>
               <a:rPr lang="en-US" sz="1600" dirty="0"/>
-              <a:t>Loss: binary cross-entropy. Layer sizes and dimensions: [fill from code].</a:t>
+              <a:t>Loss: binary cross-entropy. Layer sizes and dimensions: 2 message-passing layers, hidden size 64, 17 node features and 6 edge features plus an 8-dim time encoding, mean + max aggregation, 1 output logit (28,897 trainable parameters; GraphSAGE baseline 10,561).</a:t>
             </a:r>
           </a:p>
           <a:p>
@@ -10370,7 +10651,7 @@
             </a:pPr>
             <a:r>
               <a:rPr lang="en-US" sz="1600" dirty="0"/>
-              <a:t>Pretrained model: none, trained from scratch [confirm].</a:t>
+              <a:t>Pretrained model: none, trained from scratch.</a:t>
             </a:r>
           </a:p>
           <a:p>

</xml_diff>